<commit_message>
Week 05: use the .docx files directly, remove the tutorial PDF copies
- Move the tutorial sheet to 3 Tutorial and the answers to 4 Tutorial Answers
  (from 5 Source Files).
- Delete the two tutorial PDFs exported from those files (same content and version).
- Keep the lecture PDF: the .pptx has three hidden slides (3, 22, 23).
- Lecture .pptx: slide 16 "build in cities 2 and 4"; slides 29-30 "order at most
  2 different items"; document title.
- Answers .docx: Q1 note on why MATLAB's fval is negative.
- Demo 4 notebook: binary variables are on PDF pages 23-24 (text only).
- intlinprog_pyomo.py, knapsack_tutorial_b.py: comments match the variables
  (no upper bound; integer, not binary).

Co-Authored-By: Claude Opus 5.5 <noreply@anthropic.com>
Claude-Session: https://claude.ai/code/session_011L96qGzUPBBiMDbr8uXoF8

[skip ci]
</commit_message>
<xml_diff>
--- a/content/Lectures/Semester 1/Week 05 - Mixed Integer Programming/5 Source Files/Week 5 - Mixed Integer Programming.pptx
+++ b/content/Lectures/Semester 1/Week 05 - Mixed Integer Programming/5 Source Files/Week 5 - Mixed Integer Programming.pptx
@@ -10515,7 +10515,7 @@
             </a:pPr>
             <a:r>
               <a:rPr lang="en-GB" sz="2400" dirty="0"/>
-              <a:t>By inspection, build for city 2 and 4.</a:t>
+              <a:t>By inspection, build in cities 2 and 4.</a:t>
             </a:r>
           </a:p>
           <a:p>
@@ -28039,7 +28039,7 @@
                 </a:pPr>
                 <a:r>
                   <a:rPr lang="en-GB" sz="1600" dirty="0"/>
-                  <a:t>You can order amounts of at most 2 items</a:t>
+                  <a:t>You can order at most 2 different items</a:t>
                 </a:r>
               </a:p>
               <a:p>
@@ -29631,7 +29631,7 @@
                 </a:pPr>
                 <a:r>
                   <a:rPr lang="en-GB" sz="1600" dirty="0"/>
-                  <a:t>You can order amounts of at most 2 items</a:t>
+                  <a:t>You can order at most 2 different items</a:t>
                 </a:r>
               </a:p>
               <a:p>

</xml_diff>